<commit_message>
Perbaiki kalimat slide uji struktur 1/3: konsistensi dimensi, istilah batas model, cara membaca hasil
Co-Authored-By: Claude Opus 5.5 <noreply@anthropic.com>
Claude-Session: https://claude.ai/code/session_01RwTK1q8JkWDwXbpfgwmLot
</commit_message>
<xml_diff>
--- a/Slide - Uji Struktur (3 slide).pptx
+++ b/Slide - Uji Struktur (3 slide).pptx
@@ -1140,7 +1140,7 @@
           <a:lstStyle/>
           <a:p>
             <a:r>
-              <a:t>Uji struktur saya mulai dari tiga pemeriksaan dasar. Pertama, kesesuaian struktur dan parameter: setiap variabel saya telusuri dan sumber serta landasannya saya catat, sehingga setiap hubungan sebab-akibat punya dasar teori atau bukti empiris. Kedua, konsistensi dimensi: Units Check dan Check Model di Vensim menampilkan "Units are OK" dan "Model is OK", artinya satuan seluruh persamaan konsisten. Ketiga, kecukupan batas model: model memuat 61 variabel, 26 dihitung di dalam model dan 35 merupakan input, serta 15 aspek sengaja dikeluarkan beserta konsekuensinya. Karena itu hasil model tidak dipakai untuk menjelaskan harga, promosi, musim, atau guncangan. Daftar lengkapnya ada di Lampiran 9.</a:t>
+              <a:t>Uji struktur saya mulai dari tiga pemeriksaan dasar. Pertama, kesesuaian struktur dan parameter: setiap variabel saya telusuri dan sumber serta landasannya saya catat, sehingga setiap hubungan sebab-akibat punya dasar teori atau bukti empiris. Kedua, konsistensi dimensi: Units Check dan Check Model di Vensim menampilkan "Units are OK" dan "Model is OK", artinya satuan seluruh persamaan konsisten. Ketiga, kecukupan batas model: model memuat 61 variabel, 26 dihitung di dalam model dan 35 merupakan input yang ditetapkan dari luar, serta 15 aspek sengaja dikeluarkan beserta konsekuensinya. Karena itu hasil model tidak dipakai untuk menjelaskan harga, promosi, musim, atau kejadian mendadak seperti pandemi dan bencana. Daftar lengkapnya ada di Lampiran 9.</a:t>
             </a:r>
           </a:p>
         </p:txBody>
@@ -7247,7 +7247,7 @@
                 </a:solidFill>
                 <a:latin typeface="Calibri (MS)"/>
               </a:rPr>
-              <a:t>Apakah satuan di sisi kiri dan kanan setiap persamaan cocok?</a:t>
+              <a:t>Apakah satuan dalam setiap persamaan sudah sesuai? Misalnya, jumlah wisatawan tidak boleh dijumlahkan dengan luas lahan.</a:t>
             </a:r>
           </a:p>
           <a:p>
@@ -7272,7 +7272,7 @@
                 </a:solidFill>
                 <a:latin typeface="Calibri (MS)"/>
               </a:rPr>
-              <a:t>Units Check dan Check Model pada Vensim untuk seluruh persamaan.</a:t>
+              <a:t>Seluruh persamaan diperiksa otomatis dengan fitur Units Check dan Check Model di Vensim.</a:t>
             </a:r>
           </a:p>
           <a:p>
@@ -7297,7 +7297,7 @@
                 </a:solidFill>
                 <a:latin typeface="Calibri (MS)"/>
               </a:rPr>
-              <a:t>Tidak ada ketidaksesuaian satuan (lihat pesan Vensim di samping).</a:t>
+              <a:t>Tidak ditemukan satuan yang tidak sesuai (pesan Vensim: “Units are OK” dan “Model is OK.”).</a:t>
             </a:r>
           </a:p>
         </p:txBody>
@@ -7562,7 +7562,7 @@
                 </a:solidFill>
                 <a:latin typeface="Calibri (MS) Bold"/>
               </a:rPr>
-              <a:t>variabel endogen</a:t>
+              <a:t>variabel dihitung model</a:t>
             </a:r>
           </a:p>
           <a:p>
@@ -7578,7 +7578,7 @@
                 </a:solidFill>
                 <a:latin typeface="Calibri (MS)"/>
               </a:rPr>
-              <a:t>dihitung di dalam model: stok, aliran, variabel turunan</a:t>
+              <a:t>nilainya berubah mengikuti hubungan di dalam model</a:t>
             </a:r>
           </a:p>
         </p:txBody>
@@ -7648,7 +7648,7 @@
                 </a:solidFill>
                 <a:latin typeface="Calibri (MS) Bold"/>
               </a:rPr>
-              <a:t>variabel eksogen</a:t>
+              <a:t>variabel input</a:t>
             </a:r>
           </a:p>
           <a:p>
@@ -7664,7 +7664,7 @@
                 </a:solidFill>
                 <a:latin typeface="Calibri (MS)"/>
               </a:rPr>
-              <a:t>input dari luar model: data, regulasi, asumsi, kebijakan</a:t>
+              <a:t>nilainya ditetapkan dari luar: data, regulasi, asumsi, kebijakan</a:t>
             </a:r>
           </a:p>
         </p:txBody>
@@ -7734,7 +7734,7 @@
                 </a:solidFill>
                 <a:latin typeface="Calibri (MS) Bold"/>
               </a:rPr>
-              <a:t>aspek dikeluarkan</a:t>
+              <a:t>aspek di luar cakupan</a:t>
             </a:r>
           </a:p>
           <a:p>
@@ -7750,7 +7750,7 @@
                 </a:solidFill>
                 <a:latin typeface="Calibri (MS)"/>
               </a:rPr>
-              <a:t>dicatat alasan &amp; konsekuensinya (Lampiran 9)</a:t>
+              <a:t>alasan dan dampaknya terhadap hasil dicatat (Lampiran 9)</a:t>
             </a:r>
           </a:p>
         </p:txBody>
@@ -7811,7 +7811,7 @@
                 </a:solidFill>
                 <a:latin typeface="Calibri (MS) Bold"/>
               </a:rPr>
-              <a:t>Batas tafsir hasil model</a:t>
+              <a:t>Cara membaca hasil model</a:t>
             </a:r>
           </a:p>
           <a:p>
@@ -7821,16 +7821,16 @@
               </a:spcAft>
             </a:pPr>
             <a:r>
-              <a:rPr sz="1320" b="0" i="0">
+              <a:rPr sz="1260" b="0" i="0">
                 <a:solidFill>
                   <a:srgbClr val="14313B"/>
                 </a:solidFill>
                 <a:latin typeface="Calibri (MS)"/>
               </a:rPr>
-              <a:t>Model </a:t>
-            </a:r>
-            <a:r>
-              <a:rPr sz="1320" b="1" i="0">
+              <a:t>Hasil menggambarkan arah perkembangan jangka panjang dalam kondisi normal, dan </a:t>
+            </a:r>
+            <a:r>
+              <a:rPr sz="1260" b="1" i="0">
                 <a:solidFill>
                   <a:srgbClr val="E4604F"/>
                 </a:solidFill>
@@ -7839,13 +7839,13 @@
               <a:t>tidak</a:t>
             </a:r>
             <a:r>
-              <a:rPr sz="1320" b="0" i="0">
+              <a:rPr sz="1260" b="0" i="0">
                 <a:solidFill>
                   <a:srgbClr val="14313B"/>
                 </a:solidFill>
                 <a:latin typeface="Calibri (MS)"/>
               </a:rPr>
-              <a:t> dirancang untuk menjelaskan:</a:t>
+              <a:t> dapat dipakai untuk menjelaskan pengaruh:</a:t>
             </a:r>
           </a:p>
           <a:p>
@@ -7855,7 +7855,7 @@
               </a:spcAft>
             </a:pPr>
             <a:r>
-              <a:rPr sz="1320" b="0" i="0">
+              <a:rPr sz="1260" b="0" i="0">
                 <a:solidFill>
                   <a:srgbClr val="14313B"/>
                 </a:solidFill>
@@ -7871,7 +7871,7 @@
               </a:spcAft>
             </a:pPr>
             <a:r>
-              <a:rPr sz="1320" b="0" i="0">
+              <a:rPr sz="1260" b="0" i="0">
                 <a:solidFill>
                   <a:srgbClr val="14313B"/>
                 </a:solidFill>
@@ -7887,13 +7887,13 @@
               </a:spcAft>
             </a:pPr>
             <a:r>
-              <a:rPr sz="1320" b="0" i="0">
+              <a:rPr sz="1260" b="0" i="0">
                 <a:solidFill>
                   <a:srgbClr val="14313B"/>
                 </a:solidFill>
                 <a:latin typeface="Calibri (MS)"/>
               </a:rPr>
-              <a:t>•  musim dan fluktuasi bulanan</a:t>
+              <a:t>•  musim ramai/sepi dalam setahun</a:t>
             </a:r>
           </a:p>
           <a:p>
@@ -7903,13 +7903,13 @@
               </a:spcAft>
             </a:pPr>
             <a:r>
-              <a:rPr sz="1320" b="0" i="0">
+              <a:rPr sz="1260" b="0" i="0">
                 <a:solidFill>
                   <a:srgbClr val="14313B"/>
                 </a:solidFill>
                 <a:latin typeface="Calibri (MS)"/>
               </a:rPr>
-              <a:t>•  guncangan: pandemi, erupsi, gempa</a:t>
+              <a:t>•  kejadian mendadak: pandemi, erupsi, gempa</a:t>
             </a:r>
           </a:p>
           <a:p>
@@ -7995,7 +7995,7 @@
                 </a:solidFill>
                 <a:latin typeface="Calibri (MS)"/>
               </a:rPr>
-              <a:t>Struktur model dapat dipertanggungjawabkan secara teori dan matematis, dan hasilnya dibaca sebagai lintasan jangka panjang tanpa guncangan.</a:t>
+              <a:t>Struktur model dapat dipertanggungjawabkan secara teori dan matematis, dan hasilnya dibaca sebagai arah perkembangan jangka panjang dalam kondisi normal.</a:t>
             </a:r>
           </a:p>
         </p:txBody>

</xml_diff>

<commit_message>
Sederhanakan bahasa slide uji struktur 2/3 dan 3/3
Co-Authored-By: Claude Opus 5.5 <noreply@anthropic.com>
Claude-Session: https://claude.ai/code/session_01RwTK1q8JkWDwXbpfgwmLot
</commit_message>
<xml_diff>
--- a/Slide - Uji Struktur (3 slide).pptx
+++ b/Slide - Uji Struktur (3 slide).pptx
@@ -223,22 +223,22 @@
               <c:strCache>
                 <c:ptCount val="7"/>
                 <c:pt idx="0">
-                  <c:v>Semua rem dimatikan (R1 murni)</c:v>
+                  <c:v>Semua balancing loop nonaktif (tinggal R1)</c:v>
                 </c:pt>
                 <c:pt idx="1">
-                  <c:v>Goal-seeking tenaga kerja dimatikan</c:v>
+                  <c:v>Penyesuaian tenaga kerja nonaktif</c:v>
                 </c:pt>
                 <c:pt idx="2">
-                  <c:v>Okupansi akomodasi dimatikan</c:v>
+                  <c:v>Okupansi akomodasi nonaktif</c:v>
                 </c:pt>
                 <c:pt idx="3">
-                  <c:v>R2 ekonomi–objek wisata dimatikan</c:v>
+                  <c:v>R2 ekonomi–objek wisata nonaktif</c:v>
                 </c:pt>
                 <c:pt idx="4">
-                  <c:v>Daya dukung lahan dimatikan</c:v>
+                  <c:v>Daya dukung lahan nonaktif</c:v>
                 </c:pt>
                 <c:pt idx="5">
-                  <c:v>B1 kepadatan dimatikan</c:v>
+                  <c:v>B1 kepadatan nonaktif</c:v>
                 </c:pt>
                 <c:pt idx="6">
                   <c:v>Simulasi dasar (semua loop aktif)</c:v>
@@ -1351,7 +1351,7 @@
           <a:lstStyle/>
           <a:p>
             <a:r>
-              <a:t>Uji kekekalan materi memeriksa apakah setiap stok benar-benar hasil akumulasi alirannya. Contohnya hotel: 2.291 ditambah konstruksi 158,18 dikurangi demolisi 114,55 menghasilkan 2.334,63, sama persis dengan nilai stok 2026 hasil simulasi. Pada kelima stok selisihnya nol sepanjang 2025 sampai 2049. Uji feedback loop dilakukan dengan mematikan satu loop pada satu waktu. Rem kepadatan B1 paling kuat: tanpa B1, wisatawan 2050 naik 160 persen. Daya dukung lahan dampaknya moderat tetapi menyentuh keenam variabel. Mematikan R2 justru menurunkan wisatawan dan paling besar menurunkan ODTW. Okupansi dan goal-seeking tenaga kerja hanya memengaruhi satu variabel. Menariknya, mematikan B1 saja menghasilkan angka lebih tinggi daripada mematikan semua rem, karena R2 tetap mendorong daya tarik naik. Jadi efek antarloop tidak bisa dijumlahkan begitu saja.</a:t>
+              <a:t>Uji kekekalan materi memeriksa apakah jumlah pada setiap stok hanya berubah karena yang bertambah dan yang berkurang. Contohnya hotel: 2.291 ditambah 158,18 yang dibangun dikurangi 114,55 yang ditutup menghasilkan 2.334,63, sama persis dengan jumlah hotel 2026 hasil simulasi. Pada kelima stok selisihnya nol sepanjang 2025 sampai 2049. Uji feedback loop dilakukan dengan menonaktifkan satu loop pada satu waktu, yaitu menahan variabel penghubung loop tetap pada nilai 2025. Loop kepadatan B1 paling berpengaruh: tanpa B1, wisatawan 2050 naik 160 persen. Daya dukung lahan pengaruhnya sedang tetapi menyentuh keenam variabel utama. Menonaktifkan R2 justru menurunkan wisatawan dan paling besar menurunkan ODTW. Okupansi akomodasi dan penyesuaian tenaga kerja hanya memengaruhi satu variabel. Menariknya, menonaktifkan B1 saja menghasilkan angka lebih tinggi daripada menonaktifkan semua balancing loop, karena R2 tetap menaikkan daya tarik. Jadi pengaruh antarloop tidak bisa dijumlahkan begitu saja.</a:t>
             </a:r>
           </a:p>
         </p:txBody>
@@ -1562,7 +1562,7 @@
           <a:lstStyle/>
           <a:p>
             <a:r>
-              <a:t>Uji kondisi ekstrem menguji 17 kombinasi nilai ekstrem pada lima subsistem dengan enam aturan fisik, misalnya TPK tidak boleh lebih dari satu dan lahan tidak boleh melebihi luas wilayah. Uji awal menemukan empat titik struktur yang bisa melanggar aturan, lalu diperbaiki dengan menambahkan pembatas. Setelah perbaikan, 15 uji lolos, 2 lolos dengan catatan, dan tidak ada yang gagal. Buktinya, pada E04 TPK mendatar tepat di satu meskipun rasio permintaan mencapai 2,27, dan pada E09 rasio daya dukung lahan turun tepat ke nol. E02 dan E15 diberi catatan karena sengaja mendorong model jauh di luar batas berlakunya, yaitu laju pertumbuhan eksternal sekitar 0,336. Pada E15, lahan sempat melewati luas wilayah 57,70 hektar dengan langkah waktu satu tahun. Ketika langkah waktu diperkecil, pelanggarannya menyusut lalu hilang pada 0,25 tahun. Artinya ini error hitungan numerik, bukan kesalahan struktur. Dengan demikian model valid secara struktural dan dapat dilanjutkan ke uji perilaku.</a:t>
+              <a:t>Uji kondisi ekstrem memberi nilai ekstrem pada parameter, misalnya dinolkan atau dikali sepuluh, lalu memeriksa apakah hasilnya tetap masuk akal dengan enam syarat, misalnya TPK tidak boleh lebih dari 100 persen dan lahan terbangun tidak boleh melebihi luas wilayah. Uji awal menemukan empat persamaan yang bisa menghasilkan nilai tidak masuk akal, lalu saya beri batas. Setelah itu, 15 uji lolos, 2 lolos dengan catatan, dan tidak ada yang gagal. Contohnya, saat investasi dinolkan, TPK berhenti tepat di 100 persen meskipun permintaan kamar 2,27 kali kapasitas, dan saat konversi lahan dikali sepuluh, rasio daya dukung lahan turun tepat ke nol. E02 dan E15 diberi catatan karena sengaja mendorong model jauh di luar batas berlakunya. Uji error integrasi memeriksa ketelitian langkah hitung. Model menghitung tahun demi tahun; pada E15 lahan sempat melewati luas wilayah 57,70 hektar. Ketika langkah hitung diperkecil, selisih itu mengecil lalu hilang pada 0,25 tahun. Artinya penyebabnya cara menghitung, bukan struktur model. Dengan demikian model valid secara struktural dan dapat lanjut ke uji perilaku.</a:t>
             </a:r>
           </a:p>
         </p:txBody>
@@ -8427,7 +8427,7 @@
                 <a:cs typeface="Calibri (MS) Bold"/>
                 <a:sym typeface="Calibri (MS) Bold"/>
               </a:rPr>
-              <a:t>Tidak ada stok yang “bocor”, dan setiap loop dalam CLD bekerja sesuai rancangannya</a:t>
+              <a:t>Jumlah pada setiap stok selalu cocok dengan hitungan tambah-kurangnya, dan setiap loop berpengaruh sesuai rancangan CLD</a:t>
             </a:r>
           </a:p>
         </p:txBody>
@@ -10486,7 +10486,7 @@
         <p:spPr>
           <a:xfrm>
             <a:off x="822960" y="2286000"/>
-            <a:ext cx="6949440" cy="1051560"/>
+            <a:ext cx="6949440" cy="1097280"/>
           </a:xfrm>
           <a:prstGeom prst="roundRect">
             <a:avLst>
@@ -10527,7 +10527,7 @@
               </a:spcAft>
             </a:pPr>
             <a:r>
-              <a:rPr sz="1440" b="1" i="0">
+              <a:rPr sz="1320" b="1" i="0">
                 <a:solidFill>
                   <a:srgbClr val="0B5E6E"/>
                 </a:solidFill>
@@ -10536,13 +10536,13 @@
               <a:t>Pertanyaan  </a:t>
             </a:r>
             <a:r>
-              <a:rPr sz="1440" b="0" i="0">
+              <a:rPr sz="1320" b="0" i="0">
                 <a:solidFill>
                   <a:srgbClr val="14313B"/>
                 </a:solidFill>
                 <a:latin typeface="Calibri (MS)"/>
               </a:rPr>
-              <a:t>Adakah wisatawan, hotel, ODTW, tenaga kerja, atau lahan yang muncul/hilang di luar aliran?</a:t>
+              <a:t>Apakah jumlah pada setiap stok hanya berubah karena yang bertambah dan yang berkurang, tanpa ada selisih yang tidak jelas asalnya?</a:t>
             </a:r>
           </a:p>
         </p:txBody>
@@ -10555,8 +10555,8 @@
         </p:nvSpPr>
         <p:spPr>
           <a:xfrm>
-            <a:off x="822960" y="3474720"/>
-            <a:ext cx="6949440" cy="1325880"/>
+            <a:off x="822960" y="3520440"/>
+            <a:ext cx="6949440" cy="1371600"/>
           </a:xfrm>
           <a:prstGeom prst="roundRect">
             <a:avLst>
@@ -10597,13 +10597,13 @@
               </a:spcAft>
             </a:pPr>
             <a:r>
-              <a:rPr sz="1380" b="1" i="0">
+              <a:rPr sz="1320" b="1" i="0">
                 <a:solidFill>
                   <a:srgbClr val="0B5E6E"/>
                 </a:solidFill>
                 <a:latin typeface="Calibri (MS) Bold"/>
               </a:rPr>
-              <a:t>Stok tahun depan = stok tahun ini + aliran masuk − aliran keluar</a:t>
+              <a:t>Jumlah tahun depan = jumlah tahun ini + yang bertambah − yang berkurang</a:t>
             </a:r>
           </a:p>
           <a:p>
@@ -10628,7 +10628,7 @@
                 </a:solidFill>
                 <a:latin typeface="Calibri (MS)"/>
               </a:rPr>
-              <a:t>2.291 + 158,17937 − 114,55 = 2.334,62937 unit</a:t>
+              <a:t>2.291 + 158,18 (dibangun) − 114,55 (ditutup) = 2.334,63 unit</a:t>
             </a:r>
           </a:p>
           <a:p>
@@ -10644,7 +10644,7 @@
                 </a:solidFill>
                 <a:latin typeface="Calibri (MS) Bold"/>
               </a:rPr>
-              <a:t>= nilai stok 2026 hasil simulasi ✓</a:t>
+              <a:t>= jumlah hotel 2026 pada hasil simulasi ✓</a:t>
             </a:r>
           </a:p>
         </p:txBody>
@@ -10658,8 +10658,8 @@
           <p:nvPr/>
         </p:nvGraphicFramePr>
         <p:xfrm>
-          <a:off x="822960" y="4937760"/>
-          <a:ext cx="6949438" cy="2907792"/>
+          <a:off x="822960" y="5029200"/>
+          <a:ext cx="6949439" cy="2743200"/>
         </p:xfrm>
         <a:graphic>
           <a:graphicData uri="http://schemas.openxmlformats.org/drawingml/2006/table">
@@ -10668,11 +10668,11 @@
                 <a:tableStyleId>{5C22544A-7EE6-4342-B048-85BDC9FD1C3A}</a:tableStyleId>
               </a:tblPr>
               <a:tblGrid>
-                <a:gridCol w="3281679"/>
-                <a:gridCol w="2413000"/>
-                <a:gridCol w="1254759"/>
+                <a:gridCol w="3185159"/>
+                <a:gridCol w="2606040"/>
+                <a:gridCol w="1158240"/>
               </a:tblGrid>
-              <a:tr h="484632">
+              <a:tr h="457200">
                 <a:tc>
                   <a:txBody>
                     <a:bodyPr wrap="square"/>
@@ -10708,7 +10708,7 @@
                           </a:solidFill>
                           <a:latin typeface="Calibri (MS) Bold"/>
                         </a:rPr>
-                        <a:t>Selisih maks. 2025–2049</a:t>
+                        <a:t>Selisih terbesar 2025–2049</a:t>
                       </a:r>
                     </a:p>
                   </a:txBody>
@@ -10731,7 +10731,7 @@
                           </a:solidFill>
                           <a:latin typeface="Calibri (MS) Bold"/>
                         </a:rPr>
-                        <a:t>Status</a:t>
+                        <a:t>Hasil</a:t>
                       </a:r>
                     </a:p>
                   </a:txBody>
@@ -10742,7 +10742,7 @@
                   </a:tcPr>
                 </a:tc>
               </a:tr>
-              <a:tr h="484632">
+              <a:tr h="457200">
                 <a:tc>
                   <a:txBody>
                     <a:bodyPr wrap="square"/>
@@ -10801,7 +10801,7 @@
                           </a:solidFill>
                           <a:latin typeface="Calibri (MS)"/>
                         </a:rPr>
-                        <a:t>Kekal</a:t>
+                        <a:t>Sesuai</a:t>
                       </a:r>
                     </a:p>
                   </a:txBody>
@@ -10812,7 +10812,7 @@
                   </a:tcPr>
                 </a:tc>
               </a:tr>
-              <a:tr h="484632">
+              <a:tr h="457200">
                 <a:tc>
                   <a:txBody>
                     <a:bodyPr wrap="square"/>
@@ -10871,7 +10871,7 @@
                           </a:solidFill>
                           <a:latin typeface="Calibri (MS)"/>
                         </a:rPr>
-                        <a:t>Kekal</a:t>
+                        <a:t>Sesuai</a:t>
                       </a:r>
                     </a:p>
                   </a:txBody>
@@ -10882,7 +10882,7 @@
                   </a:tcPr>
                 </a:tc>
               </a:tr>
-              <a:tr h="484632">
+              <a:tr h="457200">
                 <a:tc>
                   <a:txBody>
                     <a:bodyPr wrap="square"/>
@@ -10941,7 +10941,7 @@
                           </a:solidFill>
                           <a:latin typeface="Calibri (MS)"/>
                         </a:rPr>
-                        <a:t>Kekal</a:t>
+                        <a:t>Sesuai</a:t>
                       </a:r>
                     </a:p>
                   </a:txBody>
@@ -10952,7 +10952,7 @@
                   </a:tcPr>
                 </a:tc>
               </a:tr>
-              <a:tr h="484632">
+              <a:tr h="457200">
                 <a:tc>
                   <a:txBody>
                     <a:bodyPr wrap="square"/>
@@ -11011,7 +11011,7 @@
                           </a:solidFill>
                           <a:latin typeface="Calibri (MS)"/>
                         </a:rPr>
-                        <a:t>Kekal</a:t>
+                        <a:t>Sesuai</a:t>
                       </a:r>
                     </a:p>
                   </a:txBody>
@@ -11022,7 +11022,7 @@
                   </a:tcPr>
                 </a:tc>
               </a:tr>
-              <a:tr h="484632">
+              <a:tr h="457200">
                 <a:tc>
                   <a:txBody>
                     <a:bodyPr wrap="square"/>
@@ -11081,7 +11081,7 @@
                           </a:solidFill>
                           <a:latin typeface="Calibri (MS)"/>
                         </a:rPr>
-                        <a:t>Kekal</a:t>
+                        <a:t>Sesuai</a:t>
                       </a:r>
                     </a:p>
                   </a:txBody>
@@ -11098,7 +11098,46 @@
       </p:graphicFrame>
       <p:sp>
         <p:nvSpPr>
-          <p:cNvPr id="127" name="Rounded Rectangle 126"/>
+          <p:cNvPr id="127" name="TextBox 126"/>
+          <p:cNvSpPr txBox="1"/>
+          <p:nvPr/>
+        </p:nvSpPr>
+        <p:spPr>
+          <a:xfrm>
+            <a:off x="822960" y="7799831"/>
+            <a:ext cx="6949440" cy="274320"/>
+          </a:xfrm>
+          <a:prstGeom prst="rect">
+            <a:avLst/>
+          </a:prstGeom>
+          <a:noFill/>
+        </p:spPr>
+        <p:txBody>
+          <a:bodyPr wrap="square" anchor="t" lIns="0" rIns="0" tIns="0" bIns="0">
+            <a:spAutoFit/>
+          </a:bodyPr>
+          <a:lstStyle/>
+          <a:p>
+            <a:pPr algn="l">
+              <a:spcAft>
+                <a:spcPts val="400"/>
+              </a:spcAft>
+            </a:pPr>
+            <a:r>
+              <a:rPr sz="1090" b="0" i="1">
+                <a:solidFill>
+                  <a:srgbClr val="5E6E78"/>
+                </a:solidFill>
+                <a:latin typeface="Calibri (MS)"/>
+              </a:rPr>
+              <a:t>Selisih = hasil simulasi dikurangi hitungan tambah-kurang di atas</a:t>
+            </a:r>
+          </a:p>
+        </p:txBody>
+      </p:sp>
+      <p:sp>
+        <p:nvSpPr>
+          <p:cNvPr id="128" name="Rounded Rectangle 127"/>
           <p:cNvSpPr/>
           <p:nvPr/>
         </p:nvSpPr>
@@ -11159,14 +11198,14 @@
                 </a:solidFill>
                 <a:latin typeface="Calibri (MS)"/>
               </a:rPr>
-              <a:t>   satu loop dimatikan, dibandingkan dengan simulasi dasar</a:t>
+              <a:t>   satu loop dinonaktifkan, lalu hasilnya dibandingkan dengan simulasi dasar</a:t>
             </a:r>
           </a:p>
         </p:txBody>
       </p:sp>
       <p:sp>
         <p:nvSpPr>
-          <p:cNvPr id="128" name="TextBox 127"/>
+          <p:cNvPr id="129" name="TextBox 128"/>
           <p:cNvSpPr txBox="1"/>
           <p:nvPr/>
         </p:nvSpPr>
@@ -11207,14 +11246,14 @@
                 </a:solidFill>
                 <a:latin typeface="Calibri (MS)"/>
               </a:rPr>
-              <a:t>  · loop dimatikan = variabel penutup loop ditahan pada nilai 2025</a:t>
+              <a:t>  · dinonaktifkan = variabel penghubung loop ditahan tetap pada nilai 2025</a:t>
             </a:r>
           </a:p>
         </p:txBody>
       </p:sp>
       <p:graphicFrame>
         <p:nvGraphicFramePr>
-          <p:cNvPr id="129" name="Chart 128"/>
+          <p:cNvPr id="130" name="Chart 129"/>
           <p:cNvGraphicFramePr>
             <a:graphicFrameLocks noGrp="1"/>
           </p:cNvGraphicFramePr>
@@ -11222,7 +11261,7 @@
         </p:nvGraphicFramePr>
         <p:xfrm>
           <a:off x="8046720" y="2606040"/>
-          <a:ext cx="9418320" cy="3383280"/>
+          <a:ext cx="9418320" cy="3154680"/>
         </p:xfrm>
         <a:graphic>
           <a:graphicData uri="http://schemas.openxmlformats.org/drawingml/2006/chart">
@@ -11232,14 +11271,14 @@
       </p:graphicFrame>
       <p:sp>
         <p:nvSpPr>
-          <p:cNvPr id="130" name="Rounded Rectangle 129"/>
+          <p:cNvPr id="131" name="Rounded Rectangle 130"/>
           <p:cNvSpPr/>
           <p:nvPr/>
         </p:nvSpPr>
         <p:spPr>
           <a:xfrm>
-            <a:off x="8046720" y="6080760"/>
-            <a:ext cx="9418320" cy="2057400"/>
+            <a:off x="8046720" y="5806440"/>
+            <a:ext cx="9418320" cy="2331720"/>
           </a:xfrm>
           <a:prstGeom prst="roundRect">
             <a:avLst>
@@ -11280,22 +11319,22 @@
               </a:spcAft>
             </a:pPr>
             <a:r>
-              <a:rPr sz="1260" b="1" i="0">
+              <a:rPr sz="1210" b="1" i="0">
                 <a:solidFill>
                   <a:srgbClr val="14313B"/>
                 </a:solidFill>
                 <a:latin typeface="Calibri (MS) Bold"/>
               </a:rPr>
-              <a:t>•  B1 kepadatan = rem terkuat: </a:t>
-            </a:r>
-            <a:r>
-              <a:rPr sz="1260" b="0" i="0">
+              <a:t>•  B1 kepadatan paling berpengaruh: </a:t>
+            </a:r>
+            <a:r>
+              <a:rPr sz="1210" b="0" i="0">
                 <a:solidFill>
                   <a:srgbClr val="14313B"/>
                 </a:solidFill>
                 <a:latin typeface="Calibri (MS)"/>
               </a:rPr>
-              <a:t>dimatikan → wisatawan +160,2%, 5 dari 6 variabel berubah &gt;1%.</a:t>
+              <a:t>tanpa B1, wisatawan 2050 naik 160,2% dan 5 dari 6 variabel utama* berubah &gt;1%.</a:t>
             </a:r>
           </a:p>
           <a:p>
@@ -11305,7 +11344,7 @@
               </a:spcAft>
             </a:pPr>
             <a:r>
-              <a:rPr sz="1260" b="1" i="0">
+              <a:rPr sz="1210" b="1" i="0">
                 <a:solidFill>
                   <a:srgbClr val="14313B"/>
                 </a:solidFill>
@@ -11314,16 +11353,16 @@
               <a:t>•  Daya dukung lahan: </a:t>
             </a:r>
             <a:r>
-              <a:rPr sz="1260" b="0" i="0">
+              <a:rPr sz="1210" b="0" i="0">
                 <a:solidFill>
                   <a:srgbClr val="14313B"/>
                 </a:solidFill>
                 <a:latin typeface="Calibri (MS)"/>
               </a:rPr>
-              <a:t>+16,1%, tetapi satu-satunya yang mengubah 6 dari 6 variabel. </a:t>
-            </a:r>
-            <a:r>
-              <a:rPr sz="1260" b="1" i="0">
+              <a:t>wisatawan naik 16,1%, tetapi memengaruhi keenam variabel utama. </a:t>
+            </a:r>
+            <a:r>
+              <a:rPr sz="1210" b="1" i="0">
                 <a:solidFill>
                   <a:srgbClr val="14313B"/>
                 </a:solidFill>
@@ -11332,13 +11371,13 @@
               <a:t>R2: </a:t>
             </a:r>
             <a:r>
-              <a:rPr sz="1260" b="0" i="0">
+              <a:rPr sz="1210" b="0" i="0">
                 <a:solidFill>
                   <a:srgbClr val="14313B"/>
                 </a:solidFill>
                 <a:latin typeface="Calibri (MS)"/>
               </a:rPr>
-              <a:t>wisatawan −16,6%, ODTW −45,3%.</a:t>
+              <a:t>wisatawan turun 16,6%, ODTW turun 45,3%.</a:t>
             </a:r>
           </a:p>
           <a:p>
@@ -11348,22 +11387,22 @@
               </a:spcAft>
             </a:pPr>
             <a:r>
-              <a:rPr sz="1260" b="1" i="0">
+              <a:rPr sz="1210" b="1" i="0">
                 <a:solidFill>
                   <a:srgbClr val="14313B"/>
                 </a:solidFill>
                 <a:latin typeface="Calibri (MS) Bold"/>
               </a:rPr>
-              <a:t>•  Dampak terbatas: </a:t>
-            </a:r>
-            <a:r>
-              <a:rPr sz="1260" b="0" i="0">
+              <a:t>•  Hanya memengaruhi satu variabel: </a:t>
+            </a:r>
+            <a:r>
+              <a:rPr sz="1210" b="0" i="0">
                 <a:solidFill>
                   <a:srgbClr val="14313B"/>
                 </a:solidFill>
                 <a:latin typeface="Calibri (MS)"/>
               </a:rPr>
-              <a:t>okupansi (hanya hotel −10,0%) dan goal-seeking tenaga kerja (hanya tenaga kerja −43,9%).</a:t>
+              <a:t>okupansi akomodasi (jumlah hotel −10,0%) dan penyesuaian tenaga kerja (tenaga kerja −43,9%).</a:t>
             </a:r>
           </a:p>
           <a:p>
@@ -11373,29 +11412,45 @@
               </a:spcAft>
             </a:pPr>
             <a:r>
-              <a:rPr sz="1260" b="1" i="0">
+              <a:rPr sz="1210" b="1" i="0">
                 <a:solidFill>
                   <a:srgbClr val="14313B"/>
                 </a:solidFill>
                 <a:latin typeface="Calibri (MS) Bold"/>
               </a:rPr>
-              <a:t>•  Efek loop tidak bisa dijumlahkan: </a:t>
-            </a:r>
-            <a:r>
-              <a:rPr sz="1260" b="0" i="0">
+              <a:t>•  Pengaruh loop tidak bisa dijumlahkan: </a:t>
+            </a:r>
+            <a:r>
+              <a:rPr sz="1210" b="0" i="0">
                 <a:solidFill>
                   <a:srgbClr val="14313B"/>
                 </a:solidFill>
                 <a:latin typeface="Calibri (MS)"/>
               </a:rPr>
-              <a:t>B1 saja dimatikan (250,32) &gt; semua rem dimatikan (217,37), karena R2 tetap menaikkan daya tarik hingga 1,0696.</a:t>
+              <a:t>menonaktifkan B1 saja (250,32 juta) lebih tinggi daripada menonaktifkan semua balancing loop (217,37 juta), karena R2 yang masih aktif terus menaikkan daya tarik hingga 1,0696.</a:t>
+            </a:r>
+          </a:p>
+          <a:p>
+            <a:pPr algn="l">
+              <a:spcAft>
+                <a:spcPts val="300"/>
+              </a:spcAft>
+            </a:pPr>
+            <a:r>
+              <a:rPr sz="1090" b="0" i="1">
+                <a:solidFill>
+                  <a:srgbClr val="5E6E78"/>
+                </a:solidFill>
+                <a:latin typeface="Calibri (MS)"/>
+              </a:rPr>
+              <a:t>* wisatawan, hotel, ODTW, tenaga kerja, lahan terbangun, daya tarik</a:t>
             </a:r>
           </a:p>
         </p:txBody>
       </p:sp>
       <p:sp>
         <p:nvSpPr>
-          <p:cNvPr id="131" name="Rounded Rectangle 130"/>
+          <p:cNvPr id="132" name="Rounded Rectangle 131"/>
           <p:cNvSpPr/>
           <p:nvPr/>
         </p:nvSpPr>
@@ -11458,14 +11513,14 @@
                 </a:solidFill>
                 <a:latin typeface="Calibri (MS)"/>
               </a:rPr>
-              <a:t>Stok hanya berubah lewat alirannya, dan setiap balancing loop yang dimatikan mempercepat pertumbuhan: keenam loop CLD bekerja sesuai rancangan.</a:t>
+              <a:t>Hitungan setiap stok cocok tanpa selisih, dan setiap balancing loop yang dinonaktifkan membuat pertumbuhan lebih cepat: keenam loop berpengaruh sesuai rancangan CLD.</a:t>
             </a:r>
           </a:p>
         </p:txBody>
       </p:sp>
       <p:sp>
         <p:nvSpPr>
-          <p:cNvPr id="132" name="TextBox 131"/>
+          <p:cNvPr id="133" name="TextBox 132"/>
           <p:cNvSpPr txBox="1"/>
           <p:nvPr/>
         </p:nvSpPr>
@@ -11890,7 +11945,7 @@
                 <a:cs typeface="Calibri (MS) Bold"/>
                 <a:sym typeface="Calibri (MS) Bold"/>
               </a:rPr>
-              <a:t>Pada nilai ekstrem model tetap logis; pelanggaran kecil pada E15 hanya error hitungan numerik</a:t>
+              <a:t>Saat parameter diberi nilai ekstrem, hasil model tetap masuk akal; selisih kecil pada E15 berasal dari langkah hitung, bukan struktur</a:t>
             </a:r>
           </a:p>
         </p:txBody>
@@ -13944,7 +13999,7 @@
                 </a:solidFill>
                 <a:latin typeface="Calibri (MS)"/>
               </a:rPr>
-              <a:t>   17 uji pada 5 subsistem, dinilai dengan 6 aturan fisik</a:t>
+              <a:t>   17 uji: parameter diberi nilai ekstrem (mis. dinolkan, dikali 10), lalu dicek dengan 6 syarat logis</a:t>
             </a:r>
           </a:p>
         </p:txBody>
@@ -13999,13 +14054,13 @@
               </a:spcAft>
             </a:pPr>
             <a:r>
-              <a:rPr sz="1210" b="1" i="0">
+              <a:rPr sz="1150" b="1" i="0">
                 <a:solidFill>
                   <a:srgbClr val="0B5E6E"/>
                 </a:solidFill>
                 <a:latin typeface="Calibri (MS) Bold"/>
               </a:rPr>
-              <a:t>Stok ≥ 0</a:t>
+              <a:t>Stok tidak negatif</a:t>
             </a:r>
           </a:p>
         </p:txBody>
@@ -14060,13 +14115,13 @@
               </a:spcAft>
             </a:pPr>
             <a:r>
-              <a:rPr sz="1210" b="1" i="0">
+              <a:rPr sz="1150" b="1" i="0">
                 <a:solidFill>
                   <a:srgbClr val="0B5E6E"/>
                 </a:solidFill>
                 <a:latin typeface="Calibri (MS) Bold"/>
               </a:rPr>
-              <a:t>TPK ≤ 1</a:t>
+              <a:t>TPK maks. 1 (100%)</a:t>
             </a:r>
           </a:p>
         </p:txBody>
@@ -14121,13 +14176,13 @@
               </a:spcAft>
             </a:pPr>
             <a:r>
-              <a:rPr sz="1210" b="1" i="0">
+              <a:rPr sz="1150" b="1" i="0">
                 <a:solidFill>
                   <a:srgbClr val="0B5E6E"/>
                 </a:solidFill>
                 <a:latin typeface="Calibri (MS) Bold"/>
               </a:rPr>
-              <a:t>RDDL ≥ 0</a:t>
+              <a:t>RDDL tidak negatif</a:t>
             </a:r>
           </a:p>
         </p:txBody>
@@ -14182,7 +14237,7 @@
               </a:spcAft>
             </a:pPr>
             <a:r>
-              <a:rPr sz="1210" b="1" i="0">
+              <a:rPr sz="1150" b="1" i="0">
                 <a:solidFill>
                   <a:srgbClr val="0B5E6E"/>
                 </a:solidFill>
@@ -14243,7 +14298,7 @@
               </a:spcAft>
             </a:pPr>
             <a:r>
-              <a:rPr sz="1210" b="1" i="0">
+              <a:rPr sz="1150" b="1" i="0">
                 <a:solidFill>
                   <a:srgbClr val="0B5E6E"/>
                 </a:solidFill>
@@ -14304,7 +14359,7 @@
               </a:spcAft>
             </a:pPr>
             <a:r>
-              <a:rPr sz="1210" b="1" i="0">
+              <a:rPr sz="1150" b="1" i="0">
                 <a:solidFill>
                   <a:srgbClr val="0B5E6E"/>
                 </a:solidFill>
@@ -14575,22 +14630,22 @@
               </a:spcAft>
             </a:pPr>
             <a:r>
-              <a:rPr sz="1260" b="1" i="0">
+              <a:rPr sz="1210" b="1" i="0">
                 <a:solidFill>
                   <a:srgbClr val="0B5E6E"/>
                 </a:solidFill>
                 <a:latin typeface="Calibri (MS) Bold"/>
               </a:rPr>
-              <a:t>4 pembatas ditambahkan setelah uji awal: </a:t>
-            </a:r>
-            <a:r>
-              <a:rPr sz="1260" b="0" i="0">
+              <a:t>Uji awal menemukan 4 persamaan yang bisa tidak masuk akal, lalu diberi batas: </a:t>
+            </a:r>
+            <a:r>
+              <a:rPr sz="1210" b="0" i="0">
                 <a:solidFill>
                   <a:srgbClr val="14313B"/>
                 </a:solidFill>
                 <a:latin typeface="Calibri (MS)"/>
               </a:rPr>
-              <a:t>TPK ≤ 1 · RDDL ≥ 0 · batas atas komponen kepadatan dan ODTW pada indeks daya tarik</a:t>
+              <a:t>TPK maks. 1, RDDL min. 0, dan nilai maksimum untuk komponen kepadatan dan ODTW pada daya tarik.</a:t>
             </a:r>
           </a:p>
         </p:txBody>
@@ -14667,7 +14722,7 @@
                 </a:solidFill>
                 <a:latin typeface="Calibri (MS)"/>
               </a:rPr>
-              <a:t>rasio investasi/PDRB = 0 → TPK naik lalu mendatar tepat di 1,000 (rasio permintaan sampai 2,267)</a:t>
+              <a:t>investasi dinolkan → TPK naik lalu berhenti tepat di 1, padahal permintaan kamar mencapai 2,267× kapasitas</a:t>
             </a:r>
           </a:p>
         </p:txBody>
@@ -14744,7 +14799,7 @@
                 </a:solidFill>
                 <a:latin typeface="Calibri (MS)"/>
               </a:rPr>
-              <a:t>laju konversi ×10 → RDDL turun tepat ke 0; lahan berhenti di luas wilayah</a:t>
+              <a:t>konversi lahan non-pariwisata ×10 → RDDL turun tepat ke 0; lahan terbangun berhenti di luas wilayah</a:t>
             </a:r>
           </a:p>
         </p:txBody>
@@ -14757,8 +14812,8 @@
         </p:nvSpPr>
         <p:spPr>
           <a:xfrm>
-            <a:off x="822960" y="6903720"/>
-            <a:ext cx="10332720" cy="1188720"/>
+            <a:off x="822960" y="6949440"/>
+            <a:ext cx="10332720" cy="1234440"/>
           </a:xfrm>
           <a:prstGeom prst="rect">
             <a:avLst/>
@@ -14777,7 +14832,7 @@
               </a:spcAft>
             </a:pPr>
             <a:r>
-              <a:rPr sz="1320" b="1" i="0">
+              <a:rPr sz="1210" b="1" i="0">
                 <a:solidFill>
                   <a:srgbClr val="0B5E6E"/>
                 </a:solidFill>
@@ -14786,31 +14841,38 @@
               <a:t>Bukti lain: </a:t>
             </a:r>
             <a:r>
-              <a:rPr sz="1320" b="0" i="0">
+              <a:rPr sz="1210" b="0" i="0">
                 <a:solidFill>
                   <a:srgbClr val="14313B"/>
                 </a:solidFill>
                 <a:latin typeface="Calibri (MS)"/>
               </a:rPr>
-              <a:t>daya tarik tetap 0,60–1,00 pada E01 &amp; E15; E10 = E11 identik; E12/E13 hanya mengubah tenaga kerja. </a:t>
-            </a:r>
-            <a:r>
-              <a:rPr sz="1320" b="1" i="0">
+              <a:t>daya tarik tetap 0,60–1,00 pada E01 &amp; E15 (tidak melonjak); E10 dan E11 hasilnya sama persis sesuai dugaan; E12/E13 hanya mengubah tenaga kerja.</a:t>
+            </a:r>
+          </a:p>
+          <a:p>
+            <a:pPr algn="l">
+              <a:spcAft>
+                <a:spcPts val="400"/>
+              </a:spcAft>
+            </a:pPr>
+            <a:r>
+              <a:rPr sz="1210" b="1" i="0">
                 <a:solidFill>
                   <a:srgbClr val="7A5A00"/>
                 </a:solidFill>
                 <a:latin typeface="Calibri (MS) Bold"/>
               </a:rPr>
-              <a:t>* E02 &amp; E15 dikecualikan dari aturan 5×: </a:t>
-            </a:r>
-            <a:r>
-              <a:rPr sz="1320" b="0" i="0">
+              <a:t>* E02 &amp; E15 tidak dinilai dengan syarat 5×: </a:t>
+            </a:r>
+            <a:r>
+              <a:rPr sz="1210" b="0" i="0">
                 <a:solidFill>
                   <a:srgbClr val="14313B"/>
                 </a:solidFill>
                 <a:latin typeface="Calibri (MS)"/>
               </a:rPr>
-              <a:t>rem sengaja dihilangkan/pendorong diperbesar. Batas berlaku model: LPE ≲ 0,336 (≈1,25× nilai dasar).</a:t>
+              <a:t>keduanya sengaja menghapus pengurang wisatawan atau melipatgandakan pertumbuhan. Model berlaku selama laju pertumbuhan eksternal (LPE) tidak melebihi sekitar 0,336 (≈1,25× nilai dasar).</a:t>
             </a:r>
           </a:p>
         </p:txBody>
@@ -14878,7 +14940,7 @@
                 </a:solidFill>
                 <a:latin typeface="Calibri (MS)"/>
               </a:rPr>
-              <a:t>   lanjutan E15</a:t>
+              <a:t>   ketelitian langkah hitung</a:t>
             </a:r>
           </a:p>
         </p:txBody>
@@ -14911,13 +14973,13 @@
               </a:spcAft>
             </a:pPr>
             <a:r>
-              <a:rPr sz="1210" b="0" i="0">
+              <a:rPr sz="1150" b="0" i="0">
                 <a:solidFill>
                   <a:srgbClr val="14313B"/>
                 </a:solidFill>
                 <a:latin typeface="Calibri (MS)"/>
               </a:rPr>
-              <a:t>Pada E15 (LPE ×3), dt 1 tahun, lahan sempat melewati luas wilayah. Salah struktur atau error hitungan?</a:t>
+              <a:t>Model menghitung per langkah waktu 1 tahun. Pada E15 (LPE ×3), lahan sempat melewati luas wilayah. Salah struktur, atau langkahnya terlalu kasar?</a:t>
             </a:r>
           </a:p>
         </p:txBody>
@@ -14938,7 +15000,7 @@
         </p:blipFill>
         <p:spPr>
           <a:xfrm>
-            <a:off x="11887200" y="2834640"/>
+            <a:off x="11887200" y="2880360"/>
             <a:ext cx="5120640" cy="2867558"/>
           </a:xfrm>
           <a:prstGeom prst="rect">
@@ -14960,7 +15022,7 @@
           <p:nvPr/>
         </p:nvGraphicFramePr>
         <p:xfrm>
-          <a:off x="11430000" y="5775350"/>
+          <a:off x="11430000" y="5821070"/>
           <a:ext cx="6035040" cy="1554480"/>
         </p:xfrm>
         <a:graphic>
@@ -14970,8 +15032,8 @@
                 <a:tableStyleId>{5C22544A-7EE6-4342-B048-85BDC9FD1C3A}</a:tableStyleId>
               </a:tblPr>
               <a:tblGrid>
-                <a:gridCol w="2103120"/>
-                <a:gridCol w="3931920"/>
+                <a:gridCol w="1828800"/>
+                <a:gridCol w="4206240"/>
               </a:tblGrid>
               <a:tr h="310896">
                 <a:tc>
@@ -14986,7 +15048,7 @@
                           </a:solidFill>
                           <a:latin typeface="Calibri (MS) Bold"/>
                         </a:rPr>
-                        <a:t>Langkah waktu (dt)</a:t>
+                        <a:t>Langkah hitung</a:t>
                       </a:r>
                     </a:p>
                   </a:txBody>
@@ -15008,7 +15070,7 @@
                           </a:solidFill>
                           <a:latin typeface="Calibri (MS) Bold"/>
                         </a:rPr>
-                        <a:t>Lahan vs luas wilayah</a:t>
+                        <a:t>Lahan terbangun vs luas wilayah</a:t>
                       </a:r>
                     </a:p>
                   </a:txBody>
@@ -15054,7 +15116,7 @@
                           </a:solidFill>
                           <a:latin typeface="Calibri (MS)"/>
                         </a:rPr>
-                        <a:t>lewat 57,70 ha (0,018%)</a:t>
+                        <a:t>melewati 57,70 ha (0,018%)</a:t>
                       </a:r>
                     </a:p>
                   </a:txBody>
@@ -15100,7 +15162,7 @@
                           </a:solidFill>
                           <a:latin typeface="Calibri (MS)"/>
                         </a:rPr>
-                        <a:t>lewat 0,01 ha</a:t>
+                        <a:t>melewati 0,01 ha</a:t>
                       </a:r>
                     </a:p>
                   </a:txBody>
@@ -15146,7 +15208,7 @@
                           </a:solidFill>
                           <a:latin typeface="Calibri (MS)"/>
                         </a:rPr>
-                        <a:t>berhenti 317.035,82 ha ✓</a:t>
+                        <a:t>berhenti di 317.035,82 ha ✓</a:t>
                       </a:r>
                     </a:p>
                   </a:txBody>
@@ -15192,7 +15254,7 @@
                           </a:solidFill>
                           <a:latin typeface="Calibri (MS)"/>
                         </a:rPr>
-                        <a:t>beda 0,06 ha dari dt 0,25</a:t>
+                        <a:t>hanya beda 0,06 ha dari 0,25</a:t>
                       </a:r>
                     </a:p>
                   </a:txBody>
@@ -15215,8 +15277,8 @@
         </p:nvSpPr>
         <p:spPr>
           <a:xfrm>
-            <a:off x="11430000" y="7384694"/>
-            <a:ext cx="6035040" cy="822960"/>
+            <a:off x="11430000" y="7430414"/>
+            <a:ext cx="6035040" cy="868680"/>
           </a:xfrm>
           <a:prstGeom prst="rect">
             <a:avLst/>
@@ -15235,13 +15297,13 @@
               </a:spcAft>
             </a:pPr>
             <a:r>
-              <a:rPr sz="1150" b="0" i="0">
+              <a:rPr sz="1090" b="0" i="0">
                 <a:solidFill>
                   <a:srgbClr val="14313B"/>
                 </a:solidFill>
                 <a:latin typeface="Calibri (MS)"/>
               </a:rPr>
-              <a:t>Selisih mengecil seiring dt diperkecil → error numerik (metode Euler), bukan struktur. Simulasi dasar dt 1 vs 0,5: −0,27% s.d. +0,34% → dt 1 tahun memadai.</a:t>
+              <a:t>Selisih hilang saat langkah diperkecil → penyebabnya cara menghitung per langkah, bukan struktur. Simulasi dasar dengan langkah 1 vs 0,5 tahun hanya beda −0,27% s.d. +0,34%, jadi langkah 1 tahun sudah cukup.</a:t>
             </a:r>
           </a:p>
         </p:txBody>
@@ -15311,7 +15373,7 @@
                 </a:solidFill>
                 <a:latin typeface="Calibri (MS)"/>
               </a:rPr>
-              <a:t>Keempat pembatas bekerja di seluruh 17 uji ekstrem, dan model valid secara struktural sehingga dapat dilanjutkan ke uji perilaku.</a:t>
+              <a:t>Keempat batas bekerja di seluruh 17 uji, dan selisih pada E15 hilang saat langkah hitung diperkecil: model valid secara struktural dan dapat lanjut ke uji perilaku.</a:t>
             </a:r>
           </a:p>
         </p:txBody>

</xml_diff>